<commit_message>
Update EBR role-play to Databricks with new metrics and initiatives
- Attendees: Naveen Zutshi, Bruce Wong, Sam Shah
- Usage slide: three-column layout with usage trends
- Value realized: velocity, agent session ROI, 65% merge rate, 3x output
- Strategic initiatives: Trust & Safety, App Integration, Billing, Core Product
- Partnership feedback: updated positives and improvement areas

Co-authored-by: Gabe Smith <gsmith432@users.noreply.github.com>
</commit_message>
<xml_diff>
--- a/ebr-interview-deck/Executive_Business_Review_ADM_Interview.pptx
+++ b/ebr-interview-deck/Executive_Business_Review_ADM_Interview.pptx
@@ -3220,7 +3220,7 @@
               </a:defRPr>
             </a:pPr>
             <a:r>
-              <a:t>Portfolio prioritization, champion strategy, and a live EBR role-play with Uber Engineering Leadership.</a:t>
+              <a:t>Portfolio prioritization, champion strategy, and a live EBR role-play with Databricks leadership.</a:t>
             </a:r>
           </a:p>
           <a:p>
@@ -3375,7 +3375,7 @@
           <a:lstStyle/>
           <a:p>
             <a:pPr>
-              <a:defRPr sz="3200" b="1">
+              <a:defRPr sz="3000" b="1">
                 <a:solidFill>
                   <a:srgbClr val="E8EDF5"/>
                 </a:solidFill>
@@ -3396,8 +3396,8 @@
         </p:nvSpPr>
         <p:spPr>
           <a:xfrm>
-            <a:off x="548640" y="1554480"/>
-            <a:ext cx="5440680" cy="4572000"/>
+            <a:off x="502920" y="1554480"/>
+            <a:ext cx="3578352" cy="4572000"/>
           </a:xfrm>
           <a:prstGeom prst="rect">
             <a:avLst/>
@@ -3441,8 +3441,8 @@
         </p:nvSpPr>
         <p:spPr>
           <a:xfrm>
-            <a:off x="731520" y="1691640"/>
-            <a:ext cx="5074920" cy="457200"/>
+            <a:off x="640080" y="1664208"/>
+            <a:ext cx="3304032" cy="411480"/>
           </a:xfrm>
           <a:prstGeom prst="rect">
             <a:avLst/>
@@ -3456,7 +3456,7 @@
           <a:lstStyle/>
           <a:p>
             <a:pPr>
-              <a:defRPr b="1" sz="1400">
+              <a:defRPr b="1" sz="1300">
                 <a:solidFill>
                   <a:srgbClr val="60A5FA"/>
                 </a:solidFill>
@@ -3477,8 +3477,8 @@
         </p:nvSpPr>
         <p:spPr>
           <a:xfrm>
-            <a:off x="731520" y="2057400"/>
-            <a:ext cx="5074920" cy="3840480"/>
+            <a:off x="640080" y="2011680"/>
+            <a:ext cx="3304032" cy="3931920"/>
           </a:xfrm>
           <a:prstGeom prst="rect">
             <a:avLst/>
@@ -3493,9 +3493,9 @@
           <a:p>
             <a:pPr>
               <a:spcAft>
-                <a:spcPts val="600"/>
+                <a:spcPts val="500"/>
               </a:spcAft>
-              <a:defRPr sz="1200">
+              <a:defRPr sz="1100">
                 <a:solidFill>
                   <a:srgbClr val="9AA8BC"/>
                 </a:solidFill>
@@ -3503,15 +3503,15 @@
               </a:defRPr>
             </a:pPr>
             <a:r>
-              <a:t>L30D active users: 8,385 (54% of SWEs)</a:t>
+              <a:t>L30D active users: 4,392 (80% of SWEs)</a:t>
             </a:r>
           </a:p>
           <a:p>
             <a:pPr>
               <a:spcAft>
-                <a:spcPts val="600"/>
+                <a:spcPts val="500"/>
               </a:spcAft>
-              <a:defRPr sz="1200">
+              <a:defRPr sz="1100">
                 <a:solidFill>
                   <a:srgbClr val="9AA8BC"/>
                 </a:solidFill>
@@ -3519,15 +3519,15 @@
               </a:defRPr>
             </a:pPr>
             <a:r>
-              <a:t>Power users: 2,757 (17.9% of SWEs)</a:t>
+              <a:t>Power users: 530 (12% of active · 9.7% of SWEs)</a:t>
             </a:r>
           </a:p>
           <a:p>
             <a:pPr>
               <a:spcAft>
-                <a:spcPts val="600"/>
+                <a:spcPts val="500"/>
               </a:spcAft>
-              <a:defRPr sz="1200">
+              <a:defRPr sz="1100">
                 <a:solidFill>
                   <a:srgbClr val="9AA8BC"/>
                 </a:solidFill>
@@ -3535,15 +3535,15 @@
               </a:defRPr>
             </a:pPr>
             <a:r>
-              <a:t>MoM active trend: +15%</a:t>
+              <a:t>Agent usage: 90% · Composer: 20%</a:t>
             </a:r>
           </a:p>
           <a:p>
             <a:pPr>
               <a:spcAft>
-                <a:spcPts val="600"/>
+                <a:spcPts val="500"/>
               </a:spcAft>
-              <a:defRPr sz="1200">
+              <a:defRPr sz="1100">
                 <a:solidFill>
                   <a:srgbClr val="9AA8BC"/>
                 </a:solidFill>
@@ -3551,15 +3551,15 @@
               </a:defRPr>
             </a:pPr>
             <a:r>
-              <a:t>Agent usage: 92% · Composer: 39.9%</a:t>
+              <a:t>Cloud Agent usage: 19.2%</a:t>
             </a:r>
           </a:p>
           <a:p>
             <a:pPr>
               <a:spcAft>
-                <a:spcPts val="600"/>
+                <a:spcPts val="500"/>
               </a:spcAft>
-              <a:defRPr sz="1200">
+              <a:defRPr sz="1100">
                 <a:solidFill>
                   <a:srgbClr val="9AA8BC"/>
                 </a:solidFill>
@@ -3567,23 +3567,7 @@
               </a:defRPr>
             </a:pPr>
             <a:r>
-              <a:t>Cloud Agent usage: 10.3%</a:t>
-            </a:r>
-          </a:p>
-          <a:p>
-            <a:pPr>
-              <a:spcAft>
-                <a:spcPts val="600"/>
-              </a:spcAft>
-              <a:defRPr sz="1200">
-                <a:solidFill>
-                  <a:srgbClr val="9AA8BC"/>
-                </a:solidFill>
-                <a:latin typeface="Segoe UI"/>
-              </a:defRPr>
-            </a:pPr>
-            <a:r>
-              <a:t>Competitor trend: +7.2% MoM</a:t>
+              <a:t>~4,000 developers onboarded in first ~5 months</a:t>
             </a:r>
           </a:p>
         </p:txBody>
@@ -3596,8 +3580,8 @@
         </p:nvSpPr>
         <p:spPr>
           <a:xfrm>
-            <a:off x="6355080" y="1554480"/>
-            <a:ext cx="5440680" cy="4572000"/>
+            <a:off x="4337304" y="1554480"/>
+            <a:ext cx="3578352" cy="4572000"/>
           </a:xfrm>
           <a:prstGeom prst="rect">
             <a:avLst/>
@@ -3641,8 +3625,8 @@
         </p:nvSpPr>
         <p:spPr>
           <a:xfrm>
-            <a:off x="6537960" y="1691640"/>
-            <a:ext cx="5074920" cy="457200"/>
+            <a:off x="4474464" y="1664208"/>
+            <a:ext cx="3304032" cy="411480"/>
           </a:xfrm>
           <a:prstGeom prst="rect">
             <a:avLst/>
@@ -3656,7 +3640,7 @@
           <a:lstStyle/>
           <a:p>
             <a:pPr>
-              <a:defRPr b="1" sz="1400">
+              <a:defRPr b="1" sz="1300">
                 <a:solidFill>
                   <a:srgbClr val="60A5FA"/>
                 </a:solidFill>
@@ -3664,7 +3648,7 @@
               </a:defRPr>
             </a:pPr>
             <a:r>
-              <a:t>Partnership timeline</a:t>
+              <a:t>Partnership to date</a:t>
             </a:r>
           </a:p>
         </p:txBody>
@@ -3677,8 +3661,8 @@
         </p:nvSpPr>
         <p:spPr>
           <a:xfrm>
-            <a:off x="6537960" y="2057400"/>
-            <a:ext cx="5074920" cy="3840480"/>
+            <a:off x="4474464" y="2011680"/>
+            <a:ext cx="3304032" cy="3931920"/>
           </a:xfrm>
           <a:prstGeom prst="rect">
             <a:avLst/>
@@ -3693,9 +3677,9 @@
           <a:p>
             <a:pPr>
               <a:spcAft>
-                <a:spcPts val="600"/>
+                <a:spcPts val="500"/>
               </a:spcAft>
-              <a:defRPr sz="1200">
+              <a:defRPr sz="1100">
                 <a:solidFill>
                   <a:srgbClr val="9AA8BC"/>
                 </a:solidFill>
@@ -3703,15 +3687,15 @@
               </a:defRPr>
             </a:pPr>
             <a:r>
-              <a:t>Q-1: Enterprise onboarding — strong rollout across Mobility &amp; Platform</a:t>
+              <a:t>Strategic ecosystem partnership — leadership QBR this quarter</a:t>
             </a:r>
           </a:p>
           <a:p>
             <a:pPr>
               <a:spcAft>
-                <a:spcPts val="600"/>
+                <a:spcPts val="500"/>
               </a:spcAft>
-              <a:defRPr sz="1200">
+              <a:defRPr sz="1100">
                 <a:solidFill>
                   <a:srgbClr val="9AA8BC"/>
                 </a:solidFill>
@@ -3719,15 +3703,15 @@
               </a:defRPr>
             </a:pPr>
             <a:r>
-              <a:t>Q0 (now): Engagement plateau; no dedicated rollout owner</a:t>
+              <a:t>Fantastic initial rollout; partner team highly responsive</a:t>
             </a:r>
           </a:p>
           <a:p>
             <a:pPr>
               <a:spcAft>
-                <a:spcPts val="600"/>
+                <a:spcPts val="500"/>
               </a:spcAft>
-              <a:defRPr sz="1200">
+              <a:defRPr sz="1100">
                 <a:solidFill>
                   <a:srgbClr val="9AA8BC"/>
                 </a:solidFill>
@@ -3735,15 +3719,15 @@
               </a:defRPr>
             </a:pPr>
             <a:r>
-              <a:t>AE pipeline: Two additional eng orgs; admin slow on intros</a:t>
+              <a:t>80% breadth adoption; opportunity to convert to depth</a:t>
             </a:r>
           </a:p>
           <a:p>
             <a:pPr>
               <a:spcAft>
-                <a:spcPts val="600"/>
+                <a:spcPts val="500"/>
               </a:spcAft>
-              <a:defRPr sz="1200">
+              <a:defRPr sz="1100">
                 <a:solidFill>
                   <a:srgbClr val="9AA8BC"/>
                 </a:solidFill>
@@ -3751,14 +3735,214 @@
               </a:defRPr>
             </a:pPr>
             <a:r>
-              <a:t>Renewal: 7 months — healthy sentiment; depth proof needed for expansion</a:t>
-            </a:r>
-          </a:p>
-        </p:txBody>
-      </p:sp>
-      <p:sp>
-        <p:nvSpPr>
-          <p:cNvPr id="10" name="TextBox 9"/>
+              <a:t>Competitor trend declining (−8.7% MoM) — momentum with Cursor</a:t>
+            </a:r>
+          </a:p>
+          <a:p>
+            <a:pPr>
+              <a:spcAft>
+                <a:spcPts val="500"/>
+              </a:spcAft>
+              <a:defRPr sz="1100">
+                <a:solidFill>
+                  <a:srgbClr val="9AA8BC"/>
+                </a:solidFill>
+                <a:latin typeface="Segoe UI"/>
+              </a:defRPr>
+            </a:pPr>
+            <a:r>
+              <a:t>Renewal in 4 months — strong sentiment, expansion upside</a:t>
+            </a:r>
+          </a:p>
+        </p:txBody>
+      </p:sp>
+      <p:sp>
+        <p:nvSpPr>
+          <p:cNvPr id="10" name="Rectangle 9"/>
+          <p:cNvSpPr/>
+          <p:nvPr/>
+        </p:nvSpPr>
+        <p:spPr>
+          <a:xfrm>
+            <a:off x="8171688" y="1554480"/>
+            <a:ext cx="3578352" cy="4572000"/>
+          </a:xfrm>
+          <a:prstGeom prst="rect">
+            <a:avLst/>
+          </a:prstGeom>
+          <a:solidFill>
+            <a:srgbClr val="18202C"/>
+          </a:solidFill>
+          <a:ln>
+            <a:solidFill>
+              <a:srgbClr val="2A3548"/>
+            </a:solidFill>
+          </a:ln>
+        </p:spPr>
+        <p:style>
+          <a:lnRef idx="1">
+            <a:schemeClr val="accent1"/>
+          </a:lnRef>
+          <a:fillRef idx="3">
+            <a:schemeClr val="accent1"/>
+          </a:fillRef>
+          <a:effectRef idx="2">
+            <a:schemeClr val="accent1"/>
+          </a:effectRef>
+          <a:fontRef idx="minor">
+            <a:schemeClr val="lt1"/>
+          </a:fontRef>
+        </p:style>
+        <p:txBody>
+          <a:bodyPr rtlCol="0" anchor="ctr"/>
+          <a:lstStyle/>
+          <a:p>
+            <a:pPr algn="ctr"/>
+          </a:p>
+        </p:txBody>
+      </p:sp>
+      <p:sp>
+        <p:nvSpPr>
+          <p:cNvPr id="11" name="TextBox 10"/>
+          <p:cNvSpPr txBox="1"/>
+          <p:nvPr/>
+        </p:nvSpPr>
+        <p:spPr>
+          <a:xfrm>
+            <a:off x="8308848" y="1664208"/>
+            <a:ext cx="3304032" cy="411480"/>
+          </a:xfrm>
+          <a:prstGeom prst="rect">
+            <a:avLst/>
+          </a:prstGeom>
+          <a:noFill/>
+        </p:spPr>
+        <p:txBody>
+          <a:bodyPr wrap="none">
+            <a:spAutoFit/>
+          </a:bodyPr>
+          <a:lstStyle/>
+          <a:p>
+            <a:pPr>
+              <a:defRPr b="1" sz="1300">
+                <a:solidFill>
+                  <a:srgbClr val="60A5FA"/>
+                </a:solidFill>
+                <a:latin typeface="Segoe UI"/>
+              </a:defRPr>
+            </a:pPr>
+            <a:r>
+              <a:t>Usage trends</a:t>
+            </a:r>
+          </a:p>
+        </p:txBody>
+      </p:sp>
+      <p:sp>
+        <p:nvSpPr>
+          <p:cNvPr id="12" name="TextBox 11"/>
+          <p:cNvSpPr txBox="1"/>
+          <p:nvPr/>
+        </p:nvSpPr>
+        <p:spPr>
+          <a:xfrm>
+            <a:off x="8308848" y="2011680"/>
+            <a:ext cx="3304032" cy="3931920"/>
+          </a:xfrm>
+          <a:prstGeom prst="rect">
+            <a:avLst/>
+          </a:prstGeom>
+          <a:noFill/>
+        </p:spPr>
+        <p:txBody>
+          <a:bodyPr wrap="square">
+            <a:spAutoFit/>
+          </a:bodyPr>
+          <a:lstStyle/>
+          <a:p>
+            <a:pPr>
+              <a:spcAft>
+                <a:spcPts val="500"/>
+              </a:spcAft>
+              <a:defRPr sz="1100">
+                <a:solidFill>
+                  <a:srgbClr val="9AA8BC"/>
+                </a:solidFill>
+                <a:latin typeface="Segoe UI"/>
+              </a:defRPr>
+            </a:pPr>
+            <a:r>
+              <a:t>MoM active users: +25.5%</a:t>
+            </a:r>
+          </a:p>
+          <a:p>
+            <a:pPr>
+              <a:spcAft>
+                <a:spcPts val="500"/>
+              </a:spcAft>
+              <a:defRPr sz="1100">
+                <a:solidFill>
+                  <a:srgbClr val="9AA8BC"/>
+                </a:solidFill>
+                <a:latin typeface="Segoe UI"/>
+              </a:defRPr>
+            </a:pPr>
+            <a:r>
+              <a:t>MoM competitor users: −8.7%</a:t>
+            </a:r>
+          </a:p>
+          <a:p>
+            <a:pPr>
+              <a:spcAft>
+                <a:spcPts val="500"/>
+              </a:spcAft>
+              <a:defRPr sz="1100">
+                <a:solidFill>
+                  <a:srgbClr val="9AA8BC"/>
+                </a:solidFill>
+                <a:latin typeface="Segoe UI"/>
+              </a:defRPr>
+            </a:pPr>
+            <a:r>
+              <a:t>Cloud adoption trending up from rollout baseline</a:t>
+            </a:r>
+          </a:p>
+          <a:p>
+            <a:pPr>
+              <a:spcAft>
+                <a:spcPts val="500"/>
+              </a:spcAft>
+              <a:defRPr sz="1100">
+                <a:solidFill>
+                  <a:srgbClr val="9AA8BC"/>
+                </a:solidFill>
+                <a:latin typeface="Segoe UI"/>
+              </a:defRPr>
+            </a:pPr>
+            <a:r>
+              <a:t>Power-user depth lagging breadth — education opportunity</a:t>
+            </a:r>
+          </a:p>
+          <a:p>
+            <a:pPr>
+              <a:spcAft>
+                <a:spcPts val="500"/>
+              </a:spcAft>
+              <a:defRPr sz="1100">
+                <a:solidFill>
+                  <a:srgbClr val="9AA8BC"/>
+                </a:solidFill>
+                <a:latin typeface="Segoe UI"/>
+              </a:defRPr>
+            </a:pPr>
+            <a:r>
+              <a:t>Agent / Cloud workflows driving fastest-growing cohort</a:t>
+            </a:r>
+          </a:p>
+        </p:txBody>
+      </p:sp>
+      <p:sp>
+        <p:nvSpPr>
+          <p:cNvPr id="13" name="TextBox 12"/>
           <p:cNvSpPr txBox="1"/>
           <p:nvPr/>
         </p:nvSpPr>
@@ -3899,7 +4083,7 @@
         <p:spPr>
           <a:xfrm>
             <a:off x="502920" y="1508760"/>
-            <a:ext cx="3611880" cy="1828800"/>
+            <a:ext cx="2697480" cy="2148840"/>
           </a:xfrm>
           <a:prstGeom prst="rect">
             <a:avLst/>
@@ -3943,8 +4127,8 @@
         </p:nvSpPr>
         <p:spPr>
           <a:xfrm>
-            <a:off x="640080" y="1618488"/>
-            <a:ext cx="3337560" cy="1645920"/>
+            <a:off x="612648" y="1618488"/>
+            <a:ext cx="2468880" cy="1920240"/>
           </a:xfrm>
           <a:prstGeom prst="rect">
             <a:avLst/>
@@ -3958,7 +4142,7 @@
           <a:lstStyle/>
           <a:p>
             <a:pPr>
-              <a:defRPr b="1" sz="1400">
+              <a:defRPr b="1" sz="1300">
                 <a:solidFill>
                   <a:srgbClr val="60A5FA"/>
                 </a:solidFill>
@@ -3966,12 +4150,12 @@
               </a:defRPr>
             </a:pPr>
             <a:r>
-              <a:t>Velocity</a:t>
-            </a:r>
-          </a:p>
-          <a:p>
-            <a:pPr>
-              <a:defRPr sz="1200">
+              <a:t>Code velocity</a:t>
+            </a:r>
+          </a:p>
+          <a:p>
+            <a:pPr>
+              <a:defRPr sz="1100">
                 <a:solidFill>
                   <a:srgbClr val="9AA8BC"/>
                 </a:solidFill>
@@ -3979,7 +4163,7 @@
               </a:defRPr>
             </a:pPr>
             <a:r>
-              <a:t>~2.4 hrs saved per dev/week on boilerplate, tests, refactors (survey n=120)</a:t>
+              <a:t>3× PRs merged for power users via Agents / Cloud workflows</a:t>
             </a:r>
           </a:p>
         </p:txBody>
@@ -3992,8 +4176,8 @@
         </p:nvSpPr>
         <p:spPr>
           <a:xfrm>
-            <a:off x="4297680" y="1508760"/>
-            <a:ext cx="3611880" cy="1828800"/>
+            <a:off x="3319272" y="1508760"/>
+            <a:ext cx="2697480" cy="2148840"/>
           </a:xfrm>
           <a:prstGeom prst="rect">
             <a:avLst/>
@@ -4037,8 +4221,8 @@
         </p:nvSpPr>
         <p:spPr>
           <a:xfrm>
-            <a:off x="4434840" y="1618488"/>
-            <a:ext cx="3337560" cy="1645920"/>
+            <a:off x="3429000" y="1618488"/>
+            <a:ext cx="2468880" cy="1920240"/>
           </a:xfrm>
           <a:prstGeom prst="rect">
             <a:avLst/>
@@ -4052,7 +4236,7 @@
           <a:lstStyle/>
           <a:p>
             <a:pPr>
-              <a:defRPr b="1" sz="1400">
+              <a:defRPr b="1" sz="1300">
                 <a:solidFill>
                   <a:srgbClr val="60A5FA"/>
                 </a:solidFill>
@@ -4060,12 +4244,12 @@
               </a:defRPr>
             </a:pPr>
             <a:r>
-              <a:t>Quality</a:t>
-            </a:r>
-          </a:p>
-          <a:p>
-            <a:pPr>
-              <a:defRPr sz="1200">
+              <a:t>Developer time</a:t>
+            </a:r>
+          </a:p>
+          <a:p>
+            <a:pPr>
+              <a:defRPr sz="1100">
                 <a:solidFill>
                   <a:srgbClr val="9AA8BC"/>
                 </a:solidFill>
@@ -4073,7 +4257,7 @@
               </a:defRPr>
             </a:pPr>
             <a:r>
-              <a:t>18% faster PR cycle time in Mobility Core (Q-1 cohort)</a:t>
+              <a:t>Every agent session ≈ 3 hrs of developer time completed</a:t>
             </a:r>
           </a:p>
         </p:txBody>
@@ -4086,8 +4270,8 @@
         </p:nvSpPr>
         <p:spPr>
           <a:xfrm>
-            <a:off x="8092440" y="1508760"/>
-            <a:ext cx="3611880" cy="1828800"/>
+            <a:off x="6135624" y="1508760"/>
+            <a:ext cx="2697480" cy="2148840"/>
           </a:xfrm>
           <a:prstGeom prst="rect">
             <a:avLst/>
@@ -4131,8 +4315,8 @@
         </p:nvSpPr>
         <p:spPr>
           <a:xfrm>
-            <a:off x="8229600" y="1618488"/>
-            <a:ext cx="3337560" cy="1645920"/>
+            <a:off x="6245352" y="1618488"/>
+            <a:ext cx="2468880" cy="1920240"/>
           </a:xfrm>
           <a:prstGeom prst="rect">
             <a:avLst/>
@@ -4146,7 +4330,7 @@
           <a:lstStyle/>
           <a:p>
             <a:pPr>
-              <a:defRPr b="1" sz="1400">
+              <a:defRPr b="1" sz="1300">
                 <a:solidFill>
                   <a:srgbClr val="60A5FA"/>
                 </a:solidFill>
@@ -4154,12 +4338,12 @@
               </a:defRPr>
             </a:pPr>
             <a:r>
-              <a:t>Scale</a:t>
-            </a:r>
-          </a:p>
-          <a:p>
-            <a:pPr>
-              <a:defRPr sz="1200">
+              <a:t>Quality at speed</a:t>
+            </a:r>
+          </a:p>
+          <a:p>
+            <a:pPr>
+              <a:defRPr sz="1100">
                 <a:solidFill>
                   <a:srgbClr val="9AA8BC"/>
                 </a:solidFill>
@@ -4167,21 +4351,66 @@
               </a:defRPr>
             </a:pPr>
             <a:r>
-              <a:t>8,385 engineers active in 90 days — fastest enterprise ramp in book</a:t>
-            </a:r>
-          </a:p>
-        </p:txBody>
-      </p:sp>
-      <p:sp>
-        <p:nvSpPr>
-          <p:cNvPr id="10" name="TextBox 9"/>
+              <a:t>65% PR merge rate — highest among tech vertical customers</a:t>
+            </a:r>
+          </a:p>
+        </p:txBody>
+      </p:sp>
+      <p:sp>
+        <p:nvSpPr>
+          <p:cNvPr id="10" name="Rectangle 9"/>
+          <p:cNvSpPr/>
+          <p:nvPr/>
+        </p:nvSpPr>
+        <p:spPr>
+          <a:xfrm>
+            <a:off x="8951976" y="1508760"/>
+            <a:ext cx="2697480" cy="2148840"/>
+          </a:xfrm>
+          <a:prstGeom prst="rect">
+            <a:avLst/>
+          </a:prstGeom>
+          <a:solidFill>
+            <a:srgbClr val="18202C"/>
+          </a:solidFill>
+          <a:ln>
+            <a:solidFill>
+              <a:srgbClr val="2A3548"/>
+            </a:solidFill>
+          </a:ln>
+        </p:spPr>
+        <p:style>
+          <a:lnRef idx="1">
+            <a:schemeClr val="accent1"/>
+          </a:lnRef>
+          <a:fillRef idx="3">
+            <a:schemeClr val="accent1"/>
+          </a:fillRef>
+          <a:effectRef idx="2">
+            <a:schemeClr val="accent1"/>
+          </a:effectRef>
+          <a:fontRef idx="minor">
+            <a:schemeClr val="lt1"/>
+          </a:fontRef>
+        </p:style>
+        <p:txBody>
+          <a:bodyPr rtlCol="0" anchor="ctr"/>
+          <a:lstStyle/>
+          <a:p>
+            <a:pPr algn="ctr"/>
+          </a:p>
+        </p:txBody>
+      </p:sp>
+      <p:sp>
+        <p:nvSpPr>
+          <p:cNvPr id="11" name="TextBox 10"/>
           <p:cNvSpPr txBox="1"/>
           <p:nvPr/>
         </p:nvSpPr>
         <p:spPr>
           <a:xfrm>
-            <a:off x="548640" y="3657600"/>
-            <a:ext cx="11064240" cy="1042416"/>
+            <a:off x="9061704" y="1618488"/>
+            <a:ext cx="2468880" cy="1920240"/>
           </a:xfrm>
           <a:prstGeom prst="rect">
             <a:avLst/>
@@ -4195,10 +4424,59 @@
           <a:lstStyle/>
           <a:p>
             <a:pPr>
+              <a:defRPr b="1" sz="1300">
+                <a:solidFill>
+                  <a:srgbClr val="60A5FA"/>
+                </a:solidFill>
+                <a:latin typeface="Segoe UI"/>
+              </a:defRPr>
+            </a:pPr>
+            <a:r>
+              <a:t>Output &amp; ROI</a:t>
+            </a:r>
+          </a:p>
+          <a:p>
+            <a:pPr>
+              <a:defRPr sz="1100">
+                <a:solidFill>
+                  <a:srgbClr val="9AA8BC"/>
+                </a:solidFill>
+                <a:latin typeface="Segoe UI"/>
+              </a:defRPr>
+            </a:pPr>
+            <a:r>
+              <a:t>Average developer ~3× output — savings scale with active cohort</a:t>
+            </a:r>
+          </a:p>
+        </p:txBody>
+      </p:sp>
+      <p:sp>
+        <p:nvSpPr>
+          <p:cNvPr id="12" name="TextBox 11"/>
+          <p:cNvSpPr txBox="1"/>
+          <p:nvPr/>
+        </p:nvSpPr>
+        <p:spPr>
+          <a:xfrm>
+            <a:off x="548640" y="3886200"/>
+            <a:ext cx="11064240" cy="1042416"/>
+          </a:xfrm>
+          <a:prstGeom prst="rect">
+            <a:avLst/>
+          </a:prstGeom>
+          <a:noFill/>
+        </p:spPr>
+        <p:txBody>
+          <a:bodyPr wrap="square">
+            <a:spAutoFit/>
+          </a:bodyPr>
+          <a:lstStyle/>
+          <a:p>
+            <a:pPr>
               <a:spcAft>
                 <a:spcPts val="600"/>
               </a:spcAft>
-              <a:defRPr sz="1500">
+              <a:defRPr sz="1400">
                 <a:solidFill>
                   <a:srgbClr val="E8EDF5"/>
                 </a:solidFill>
@@ -4206,7 +4484,7 @@
               </a:defRPr>
             </a:pPr>
             <a:r>
-              <a:t>ROI framing: 2.4 hrs/dev/week × 8,385 active × $85/hr ≈ $1.7M/month recovered capacity vs. $980K annual contract.</a:t>
+              <a:t>ROI framing: ~3× output × 4,392 active devs × 3 hrs saved per agent session → material capacity recovery.</a:t>
             </a:r>
           </a:p>
           <a:p>
@@ -4214,7 +4492,7 @@
               <a:spcAft>
                 <a:spcPts val="600"/>
               </a:spcAft>
-              <a:defRPr sz="1500">
+              <a:defRPr sz="1400">
                 <a:solidFill>
                   <a:srgbClr val="E8EDF5"/>
                 </a:solidFill>
@@ -4222,14 +4500,14 @@
               </a:defRPr>
             </a:pPr>
             <a:r>
-              <a:t>Expansion to remaining 46% of SWEs + two new orgs could 2–3× this impact.</a:t>
-            </a:r>
-          </a:p>
-        </p:txBody>
-      </p:sp>
-      <p:sp>
-        <p:nvSpPr>
-          <p:cNvPr id="11" name="TextBox 10"/>
+              <a:t>65% merge rate proves velocity gains without sacrificing quality — foundation for org-wide expansion case.</a:t>
+            </a:r>
+          </a:p>
+        </p:txBody>
+      </p:sp>
+      <p:sp>
+        <p:nvSpPr>
+          <p:cNvPr id="13" name="TextBox 12"/>
           <p:cNvSpPr txBox="1"/>
           <p:nvPr/>
         </p:nvSpPr>
@@ -4371,7 +4649,7 @@
         </p:nvGraphicFramePr>
         <p:xfrm>
           <a:off x="457200" y="1417320"/>
-          <a:ext cx="11247120" cy="2542032"/>
+          <a:ext cx="11247120" cy="2194560"/>
         </p:xfrm>
         <a:graphic>
           <a:graphicData uri="http://schemas.openxmlformats.org/drawingml/2006/table">
@@ -4384,7 +4662,7 @@
                 <a:gridCol w="3749040"/>
                 <a:gridCol w="3749040"/>
               </a:tblGrid>
-              <a:tr h="423672">
+              <a:tr h="438912">
                 <a:tc>
                   <a:txBody>
                     <a:bodyPr/>
@@ -4399,7 +4677,7 @@
                         </a:defRPr>
                       </a:pPr>
                       <a:r>
-                        <a:t>Uber initiative</a:t>
+                        <a:t>Databricks initiative</a:t>
                       </a:r>
                     </a:p>
                   </a:txBody>
@@ -4423,7 +4701,7 @@
                         </a:defRPr>
                       </a:pPr>
                       <a:r>
-                        <a:t>How Cursor supports it</a:t>
+                        <a:t>Team</a:t>
                       </a:r>
                     </a:p>
                   </a:txBody>
@@ -4447,7 +4725,7 @@
                         </a:defRPr>
                       </a:pPr>
                       <a:r>
-                        <a:t>Status</a:t>
+                        <a:t>Value delivered</a:t>
                       </a:r>
                     </a:p>
                   </a:txBody>
@@ -4458,7 +4736,7 @@
                   </a:tcPr>
                 </a:tc>
               </a:tr>
-              <a:tr h="423672">
+              <a:tr h="438912">
                 <a:tc>
                   <a:txBody>
                     <a:bodyPr wrap="square"/>
@@ -4473,7 +4751,7 @@
                         </a:defRPr>
                       </a:pPr>
                       <a:r>
-                        <a:t>Platform modernization</a:t>
+                        <a:t>Vulnerability backlog burndown</a:t>
                       </a:r>
                     </a:p>
                   </a:txBody>
@@ -4497,7 +4775,7 @@
                         </a:defRPr>
                       </a:pPr>
                       <a:r>
-                        <a:t>Agent-assisted migrations; Composer for large-scale refactors</a:t>
+                        <a:t>Trust &amp; Safety</a:t>
                       </a:r>
                     </a:p>
                   </a:txBody>
@@ -4521,7 +4799,7 @@
                         </a:defRPr>
                       </a:pPr>
                       <a:r>
-                        <a:t>Active</a:t>
+                        <a:t>Cloud Agents + Automations triage and remediate CVEs at ~30× manual pace</a:t>
                       </a:r>
                     </a:p>
                   </a:txBody>
@@ -4532,7 +4810,7 @@
                   </a:tcPr>
                 </a:tc>
               </a:tr>
-              <a:tr h="423672">
+              <a:tr h="438912">
                 <a:tc>
                   <a:txBody>
                     <a:bodyPr wrap="square"/>
@@ -4547,7 +4825,7 @@
                         </a:defRPr>
                       </a:pPr>
                       <a:r>
-                        <a:t>AI-native developer experience</a:t>
+                        <a:t>Automated test coverage reporting</a:t>
                       </a:r>
                     </a:p>
                   </a:txBody>
@@ -4571,7 +4849,7 @@
                         </a:defRPr>
                       </a:pPr>
                       <a:r>
-                        <a:t>Cloud Agents for async tasks; Automations for CI/CD workflows</a:t>
+                        <a:t>App Integration</a:t>
                       </a:r>
                     </a:p>
                   </a:txBody>
@@ -4595,7 +4873,7 @@
                         </a:defRPr>
                       </a:pPr>
                       <a:r>
-                        <a:t>Early — 10% cloud</a:t>
+                        <a:t>Agents generate coverage reports on schedule; ~30× faster than manual audits</a:t>
                       </a:r>
                     </a:p>
                   </a:txBody>
@@ -4606,7 +4884,7 @@
                   </a:tcPr>
                 </a:tc>
               </a:tr>
-              <a:tr h="423672">
+              <a:tr h="438912">
                 <a:tc>
                   <a:txBody>
                     <a:bodyPr wrap="square"/>
@@ -4621,7 +4899,7 @@
                         </a:defRPr>
                       </a:pPr>
                       <a:r>
-                        <a:t>Engineering efficiency metrics</a:t>
+                        <a:t>Synchronous → async code migration</a:t>
                       </a:r>
                     </a:p>
                   </a:txBody>
@@ -4645,7 +4923,7 @@
                         </a:defRPr>
                       </a:pPr>
                       <a:r>
-                        <a:t>ADM adoption dashboard; power-user cohort analysis</a:t>
+                        <a:t>Billing</a:t>
                       </a:r>
                     </a:p>
                   </a:txBody>
@@ -4669,7 +4947,7 @@
                         </a:defRPr>
                       </a:pPr>
                       <a:r>
-                        <a:t>In progress</a:t>
+                        <a:t>Cloud workflows migrate legacy sync patterns; ~30× efficiency vs. hand migration</a:t>
                       </a:r>
                     </a:p>
                   </a:txBody>
@@ -4680,7 +4958,7 @@
                   </a:tcPr>
                 </a:tc>
               </a:tr>
-              <a:tr h="423672">
+              <a:tr h="438912">
                 <a:tc>
                   <a:txBody>
                     <a:bodyPr wrap="square"/>
@@ -4695,7 +4973,7 @@
                         </a:defRPr>
                       </a:pPr>
                       <a:r>
-                        <a:t>Security &amp; code quality</a:t>
+                        <a:t>Bug issue triaging</a:t>
                       </a:r>
                     </a:p>
                   </a:txBody>
@@ -4719,7 +4997,7 @@
                         </a:defRPr>
                       </a:pPr>
                       <a:r>
-                        <a:t>Bugbot on PRs; custom rules for service mesh patterns</a:t>
+                        <a:t>Core Product</a:t>
                       </a:r>
                     </a:p>
                   </a:txBody>
@@ -4743,87 +5021,13 @@
                         </a:defRPr>
                       </a:pPr>
                       <a:r>
-                        <a:t>Pilot — 2 squads</a:t>
+                        <a:t>Automations + Bugbot route, classify, and draft fixes; ~30× triage throughput</a:t>
                       </a:r>
                     </a:p>
                   </a:txBody>
                   <a:tcPr anchor="t">
                     <a:solidFill>
                       <a:srgbClr val="0B0F14"/>
-                    </a:solidFill>
-                  </a:tcPr>
-                </a:tc>
-              </a:tr>
-              <a:tr h="423672">
-                <a:tc>
-                  <a:txBody>
-                    <a:bodyPr wrap="square"/>
-                    <a:lstStyle/>
-                    <a:p>
-                      <a:pPr>
-                        <a:defRPr sz="900">
-                          <a:solidFill>
-                            <a:srgbClr val="E8EDF5"/>
-                          </a:solidFill>
-                          <a:latin typeface="Segoe UI"/>
-                        </a:defRPr>
-                      </a:pPr>
-                      <a:r>
-                        <a:t>Cross-org eng standards</a:t>
-                      </a:r>
-                    </a:p>
-                  </a:txBody>
-                  <a:tcPr anchor="t">
-                    <a:solidFill>
-                      <a:srgbClr val="121820"/>
-                    </a:solidFill>
-                  </a:tcPr>
-                </a:tc>
-                <a:tc>
-                  <a:txBody>
-                    <a:bodyPr wrap="square"/>
-                    <a:lstStyle/>
-                    <a:p>
-                      <a:pPr>
-                        <a:defRPr sz="900">
-                          <a:solidFill>
-                            <a:srgbClr val="E8EDF5"/>
-                          </a:solidFill>
-                          <a:latin typeface="Segoe UI"/>
-                        </a:defRPr>
-                      </a:pPr>
-                      <a:r>
-                        <a:t>Shared .cursor/rules + champion guild (Elena leading)</a:t>
-                      </a:r>
-                    </a:p>
-                  </a:txBody>
-                  <a:tcPr anchor="t">
-                    <a:solidFill>
-                      <a:srgbClr val="121820"/>
-                    </a:solidFill>
-                  </a:tcPr>
-                </a:tc>
-                <a:tc>
-                  <a:txBody>
-                    <a:bodyPr wrap="square"/>
-                    <a:lstStyle/>
-                    <a:p>
-                      <a:pPr>
-                        <a:defRPr sz="900">
-                          <a:solidFill>
-                            <a:srgbClr val="E8EDF5"/>
-                          </a:solidFill>
-                          <a:latin typeface="Segoe UI"/>
-                        </a:defRPr>
-                      </a:pPr>
-                      <a:r>
-                        <a:t>Planned Q+1</a:t>
-                      </a:r>
-                    </a:p>
-                  </a:txBody>
-                  <a:tcPr anchor="t">
-                    <a:solidFill>
-                      <a:srgbClr val="121820"/>
                     </a:solidFill>
                   </a:tcPr>
                 </a:tc>
@@ -4974,8 +5178,8 @@
         </p:nvSpPr>
         <p:spPr>
           <a:xfrm>
-            <a:off x="548640" y="1554480"/>
-            <a:ext cx="5440680" cy="4572000"/>
+            <a:off x="502920" y="1554480"/>
+            <a:ext cx="5495544" cy="4572000"/>
           </a:xfrm>
           <a:prstGeom prst="rect">
             <a:avLst/>
@@ -5019,8 +5223,8 @@
         </p:nvSpPr>
         <p:spPr>
           <a:xfrm>
-            <a:off x="731520" y="1691640"/>
-            <a:ext cx="5074920" cy="457200"/>
+            <a:off x="640080" y="1664208"/>
+            <a:ext cx="5221224" cy="411480"/>
           </a:xfrm>
           <a:prstGeom prst="rect">
             <a:avLst/>
@@ -5042,7 +5246,7 @@
               </a:defRPr>
             </a:pPr>
             <a:r>
-              <a:t>Highlights</a:t>
+              <a:t>Positives</a:t>
             </a:r>
           </a:p>
         </p:txBody>
@@ -5055,8 +5259,8 @@
         </p:nvSpPr>
         <p:spPr>
           <a:xfrm>
-            <a:off x="731520" y="2057400"/>
-            <a:ext cx="5074920" cy="3840480"/>
+            <a:off x="640080" y="2011680"/>
+            <a:ext cx="5221224" cy="3931920"/>
           </a:xfrm>
           <a:prstGeom prst="rect">
             <a:avLst/>
@@ -5071,7 +5275,7 @@
           <a:p>
             <a:pPr>
               <a:spcAft>
-                <a:spcPts val="600"/>
+                <a:spcPts val="500"/>
               </a:spcAft>
               <a:defRPr sz="1200">
                 <a:solidFill>
@@ -5081,13 +5285,13 @@
               </a:defRPr>
             </a:pPr>
             <a:r>
-              <a:t>Fastest enterprise onboarding — 54% active in 90 days</a:t>
+              <a:t>Product usability — IDE works really well for daily engineering workflows</a:t>
             </a:r>
           </a:p>
           <a:p>
             <a:pPr>
               <a:spcAft>
-                <a:spcPts val="600"/>
+                <a:spcPts val="500"/>
               </a:spcAft>
               <a:defRPr sz="1200">
                 <a:solidFill>
@@ -5097,13 +5301,13 @@
               </a:defRPr>
             </a:pPr>
             <a:r>
-              <a:t>Strong agent adoption (92%) — daily driver, not a toy</a:t>
+              <a:t>Fantastic initial rollout: ~4,000 developers onboarded in first ~5 months</a:t>
             </a:r>
           </a:p>
           <a:p>
             <a:pPr>
               <a:spcAft>
-                <a:spcPts val="600"/>
+                <a:spcPts val="500"/>
               </a:spcAft>
               <a:defRPr sz="1200">
                 <a:solidFill>
@@ -5113,13 +5317,13 @@
               </a:defRPr>
             </a:pPr>
             <a:r>
-              <a:t>Responsive AE + ADM cadence during rollout</a:t>
+              <a:t>Partner team incredibly responsive with clear value framework for code velocity</a:t>
             </a:r>
           </a:p>
           <a:p>
             <a:pPr>
               <a:spcAft>
-                <a:spcPts val="600"/>
+                <a:spcPts val="500"/>
               </a:spcAft>
               <a:defRPr sz="1200">
                 <a:solidFill>
@@ -5129,7 +5333,7 @@
               </a:defRPr>
             </a:pPr>
             <a:r>
-              <a:t>Power-user Slack community (400+ members)</a:t>
+              <a:t>Responsive support team — no outstanding issues, all within SLA</a:t>
             </a:r>
           </a:p>
         </p:txBody>
@@ -5142,8 +5346,8 @@
         </p:nvSpPr>
         <p:spPr>
           <a:xfrm>
-            <a:off x="6355080" y="1554480"/>
-            <a:ext cx="5440680" cy="4572000"/>
+            <a:off x="6254496" y="1554480"/>
+            <a:ext cx="5495544" cy="4572000"/>
           </a:xfrm>
           <a:prstGeom prst="rect">
             <a:avLst/>
@@ -5187,8 +5391,8 @@
         </p:nvSpPr>
         <p:spPr>
           <a:xfrm>
-            <a:off x="6537960" y="1691640"/>
-            <a:ext cx="5074920" cy="457200"/>
+            <a:off x="6391656" y="1664208"/>
+            <a:ext cx="5221224" cy="411480"/>
           </a:xfrm>
           <a:prstGeom prst="rect">
             <a:avLst/>
@@ -5223,8 +5427,8 @@
         </p:nvSpPr>
         <p:spPr>
           <a:xfrm>
-            <a:off x="6537960" y="2057400"/>
-            <a:ext cx="5074920" cy="3840480"/>
+            <a:off x="6391656" y="2011680"/>
+            <a:ext cx="5221224" cy="3931920"/>
           </a:xfrm>
           <a:prstGeom prst="rect">
             <a:avLst/>
@@ -5239,7 +5443,7 @@
           <a:p>
             <a:pPr>
               <a:spcAft>
-                <a:spcPts val="600"/>
+                <a:spcPts val="500"/>
               </a:spcAft>
               <a:defRPr sz="1200">
                 <a:solidFill>
@@ -5249,13 +5453,13 @@
               </a:defRPr>
             </a:pPr>
             <a:r>
-              <a:t>Post-rollout drop-off — need quarterly touchpoints</a:t>
+              <a:t>More admin controls on which models each user can access</a:t>
             </a:r>
           </a:p>
           <a:p>
             <a:pPr>
               <a:spcAft>
-                <a:spcPts val="600"/>
+                <a:spcPts val="500"/>
               </a:spcAft>
               <a:defRPr sz="1200">
                 <a:solidFill>
@@ -5265,13 +5469,13 @@
               </a:defRPr>
             </a:pPr>
             <a:r>
-              <a:t>Admin bottleneck on cross-org introductions</a:t>
+              <a:t>Cloud adoption — highest ROI surface; currently under-penetrated vs. potential</a:t>
             </a:r>
           </a:p>
           <a:p>
             <a:pPr>
               <a:spcAft>
-                <a:spcPts val="600"/>
+                <a:spcPts val="500"/>
               </a:spcAft>
               <a:defRPr sz="1200">
                 <a:solidFill>
@@ -5281,13 +5485,13 @@
               </a:defRPr>
             </a:pPr>
             <a:r>
-              <a:t>Cloud Agent awareness: only 10% using cloud</a:t>
+              <a:t>Building a long-term adoption / education framework beyond initial rollout</a:t>
             </a:r>
           </a:p>
           <a:p>
             <a:pPr>
               <a:spcAft>
-                <a:spcPts val="600"/>
+                <a:spcPts val="500"/>
               </a:spcAft>
               <a:defRPr sz="1200">
                 <a:solidFill>
@@ -5297,23 +5501,7 @@
               </a:defRPr>
             </a:pPr>
             <a:r>
-              <a:t>Leadership wants team-level dashboards</a:t>
-            </a:r>
-          </a:p>
-          <a:p>
-            <a:pPr>
-              <a:spcAft>
-                <a:spcPts val="600"/>
-              </a:spcAft>
-              <a:defRPr sz="1200">
-                <a:solidFill>
-                  <a:srgbClr val="9AA8BC"/>
-                </a:solidFill>
-                <a:latin typeface="Segoe UI"/>
-              </a:defRPr>
-            </a:pPr>
-            <a:r>
-              <a:t>Competitor noise: +7% MoM in one Mobility squad</a:t>
+              <a:t>Strategic roadmap alignment — which top initiatives &amp; teams should we co-prioritize?</a:t>
             </a:r>
           </a:p>
         </p:txBody>
@@ -5580,7 +5768,7 @@
               </a:defRPr>
             </a:pPr>
             <a:r>
-              <a:t>• Uber fit: async refactors across monorepo</a:t>
+              <a:t>• Databricks fit: async migrations across Billing &amp; Core Product</a:t>
             </a:r>
           </a:p>
         </p:txBody>
@@ -5713,7 +5901,7 @@
               </a:defRPr>
             </a:pPr>
             <a:r>
-              <a:t>• Uber fit: PR triage, on-call → fix PR</a:t>
+              <a:t>• Databricks fit: vuln burndown, test coverage, bug triage</a:t>
             </a:r>
           </a:p>
         </p:txBody>
@@ -5846,7 +6034,7 @@
               </a:defRPr>
             </a:pPr>
             <a:r>
-              <a:t>• Uber fit: enforce service-mesh patterns</a:t>
+              <a:t>• Databricks fit: Trust &amp; Safety + Core Product quality gates</a:t>
             </a:r>
           </a:p>
         </p:txBody>
@@ -6019,7 +6207,7 @@
               </a:defRPr>
             </a:pPr>
             <a:r>
-              <a:t>Weekly PR quality automation for Uber Mobility Core</a:t>
+              <a:t>Vulnerability backlog automation for Databricks Trust &amp; Safety</a:t>
             </a:r>
           </a:p>
           <a:p>
@@ -6048,7 +6236,7 @@
               </a:defRPr>
             </a:pPr>
             <a:r>
-              <a:t>Trigger: Every Monday 9am PT · GitHub PR merged to mobility-core</a:t>
+              <a:t>Trigger: Daily 6am PT · new CVE alerts in security queue</a:t>
             </a:r>
           </a:p>
           <a:p>
@@ -6109,7 +6297,7 @@
               </a:defRPr>
             </a:pPr>
             <a:r>
-              <a:t>3. Posts summary to #mobility-eng Slack with top 3 findings</a:t>
+              <a:t>3. Posts summary to #trust-safety-eng Slack with prioritized findings</a:t>
             </a:r>
           </a:p>
           <a:p>
@@ -6154,7 +6342,7 @@
               </a:defRPr>
             </a:pPr>
             <a:r>
-              <a:t>90-day pilot: Mobility Core (1 squad) → Marketplace → org-wide Automations library</a:t>
+              <a:t>90-day pilot: Trust &amp; Safety → App Integration → org-wide Automations library</a:t>
             </a:r>
           </a:p>
         </p:txBody>
@@ -6479,7 +6667,7 @@
                         </a:defRPr>
                       </a:pPr>
                       <a:r>
-                        <a:t>Appoint rollout owner + unblock 2 eng org intros</a:t>
+                        <a:t>Strategic roadmap alignment with Naveen / Sam</a:t>
                       </a:r>
                     </a:p>
                   </a:txBody>
@@ -6503,7 +6691,7 @@
                         </a:defRPr>
                       </a:pPr>
                       <a:r>
-                        <a:t>Priya + ADM</a:t>
+                        <a:t>ADM + AE</a:t>
                       </a:r>
                     </a:p>
                   </a:txBody>
@@ -6551,7 +6739,7 @@
                         </a:defRPr>
                       </a:pPr>
                       <a:r>
-                        <a:t>Intros scheduled</a:t>
+                        <a:t>Top 4 team initiatives confirmed</a:t>
                       </a:r>
                     </a:p>
                   </a:txBody>
@@ -6601,7 +6789,7 @@
                         </a:defRPr>
                       </a:pPr>
                       <a:r>
-                        <a:t>Adoption-depth dashboard for exec visibility</a:t>
+                        <a:t>Cloud adoption education framework</a:t>
                       </a:r>
                     </a:p>
                   </a:txBody>
@@ -6625,7 +6813,7 @@
                         </a:defRPr>
                       </a:pPr>
                       <a:r>
-                        <a:t>ADM</a:t>
+                        <a:t>ADM + Bruce</a:t>
                       </a:r>
                     </a:p>
                   </a:txBody>
@@ -6673,7 +6861,7 @@
                         </a:defRPr>
                       </a:pPr>
                       <a:r>
-                        <a:t>Team-level active/cloud %</a:t>
+                        <a:t>Cloud usage 19% → 30%</a:t>
                       </a:r>
                     </a:p>
                   </a:txBody>
@@ -6723,7 +6911,7 @@
                         </a:defRPr>
                       </a:pPr>
                       <a:r>
-                        <a:t>Automations pilot (Mobility Core PR review)</a:t>
+                        <a:t>Vuln burndown Automation (Trust &amp; Safety)</a:t>
                       </a:r>
                     </a:p>
                   </a:txBody>
@@ -6747,7 +6935,7 @@
                         </a:defRPr>
                       </a:pPr>
                       <a:r>
-                        <a:t>Marcus + Elena</a:t>
+                        <a:t>Bruce + SE</a:t>
                       </a:r>
                     </a:p>
                   </a:txBody>
@@ -6795,7 +6983,7 @@
                         </a:defRPr>
                       </a:pPr>
                       <a:r>
-                        <a:t>Cloud 10% → 20%</a:t>
+                        <a:t>~30× burndown velocity</a:t>
                       </a:r>
                     </a:p>
                   </a:txBody>
@@ -6845,7 +7033,7 @@
                         </a:defRPr>
                       </a:pPr>
                       <a:r>
-                        <a:t>Bugbot rollout to 5 squads with custom rules</a:t>
+                        <a:t>Bug triage Automation (Core Product)</a:t>
                       </a:r>
                     </a:p>
                   </a:txBody>
@@ -6869,7 +7057,7 @@
                         </a:defRPr>
                       </a:pPr>
                       <a:r>
-                        <a:t>Sofia + SE</a:t>
+                        <a:t>Sam + SE</a:t>
                       </a:r>
                     </a:p>
                   </a:txBody>
@@ -6917,7 +7105,7 @@
                         </a:defRPr>
                       </a:pPr>
                       <a:r>
-                        <a:t>70%+ flag resolution</a:t>
+                        <a:t>Triage throughput 30× baseline</a:t>
                       </a:r>
                     </a:p>
                   </a:txBody>
@@ -6991,7 +7179,7 @@
                         </a:defRPr>
                       </a:pPr>
                       <a:r>
-                        <a:t>James + AE</a:t>
+                        <a:t>Naveen + AE</a:t>
                       </a:r>
                     </a:p>
                   </a:txBody>
@@ -7039,7 +7227,7 @@
                         </a:defRPr>
                       </a:pPr>
                       <a:r>
-                        <a:t>Expansion proposal for 2 orgs</a:t>
+                        <a:t>Expansion proposal presented</a:t>
                       </a:r>
                     </a:p>
                   </a:txBody>
@@ -7523,8 +7711,8 @@
         </p:nvSpPr>
         <p:spPr>
           <a:xfrm>
-            <a:off x="548640" y="1554480"/>
-            <a:ext cx="5440680" cy="4572000"/>
+            <a:off x="502920" y="1554480"/>
+            <a:ext cx="5495544" cy="4572000"/>
           </a:xfrm>
           <a:prstGeom prst="rect">
             <a:avLst/>
@@ -7568,8 +7756,8 @@
         </p:nvSpPr>
         <p:spPr>
           <a:xfrm>
-            <a:off x="731520" y="1691640"/>
-            <a:ext cx="5074920" cy="457200"/>
+            <a:off x="640080" y="1664208"/>
+            <a:ext cx="5221224" cy="411480"/>
           </a:xfrm>
           <a:prstGeom prst="rect">
             <a:avLst/>
@@ -7604,8 +7792,8 @@
         </p:nvSpPr>
         <p:spPr>
           <a:xfrm>
-            <a:off x="731520" y="2057400"/>
-            <a:ext cx="5074920" cy="3840480"/>
+            <a:off x="640080" y="2011680"/>
+            <a:ext cx="5221224" cy="3931920"/>
           </a:xfrm>
           <a:prstGeom prst="rect">
             <a:avLst/>
@@ -7620,7 +7808,7 @@
           <a:p>
             <a:pPr>
               <a:spcAft>
-                <a:spcPts val="600"/>
+                <a:spcPts val="500"/>
               </a:spcAft>
               <a:defRPr sz="1200">
                 <a:solidFill>
@@ -7636,7 +7824,7 @@
           <a:p>
             <a:pPr>
               <a:spcAft>
-                <a:spcPts val="600"/>
+                <a:spcPts val="500"/>
               </a:spcAft>
               <a:defRPr sz="1200">
                 <a:solidFill>
@@ -7652,7 +7840,7 @@
           <a:p>
             <a:pPr>
               <a:spcAft>
-                <a:spcPts val="600"/>
+                <a:spcPts val="500"/>
               </a:spcAft>
               <a:defRPr sz="1200">
                 <a:solidFill>
@@ -7665,7 +7853,7 @@
           <a:p>
             <a:pPr>
               <a:spcAft>
-                <a:spcPts val="600"/>
+                <a:spcPts val="500"/>
               </a:spcAft>
               <a:defRPr sz="1200">
                 <a:solidFill>
@@ -7681,7 +7869,7 @@
           <a:p>
             <a:pPr>
               <a:spcAft>
-                <a:spcPts val="600"/>
+                <a:spcPts val="500"/>
               </a:spcAft>
               <a:defRPr sz="1200">
                 <a:solidFill>
@@ -7697,7 +7885,7 @@
           <a:p>
             <a:pPr>
               <a:spcAft>
-                <a:spcPts val="600"/>
+                <a:spcPts val="500"/>
               </a:spcAft>
               <a:defRPr sz="1200">
                 <a:solidFill>
@@ -7713,7 +7901,7 @@
           <a:p>
             <a:pPr>
               <a:spcAft>
-                <a:spcPts val="600"/>
+                <a:spcPts val="500"/>
               </a:spcAft>
               <a:defRPr sz="1200">
                 <a:solidFill>
@@ -7736,8 +7924,8 @@
         </p:nvSpPr>
         <p:spPr>
           <a:xfrm>
-            <a:off x="6355080" y="1554480"/>
-            <a:ext cx="5440680" cy="4572000"/>
+            <a:off x="6254496" y="1554480"/>
+            <a:ext cx="5495544" cy="4572000"/>
           </a:xfrm>
           <a:prstGeom prst="rect">
             <a:avLst/>
@@ -7781,8 +7969,8 @@
         </p:nvSpPr>
         <p:spPr>
           <a:xfrm>
-            <a:off x="6537960" y="1691640"/>
-            <a:ext cx="5074920" cy="457200"/>
+            <a:off x="6391656" y="1664208"/>
+            <a:ext cx="5221224" cy="411480"/>
           </a:xfrm>
           <a:prstGeom prst="rect">
             <a:avLst/>
@@ -7817,8 +8005,8 @@
         </p:nvSpPr>
         <p:spPr>
           <a:xfrm>
-            <a:off x="6537960" y="2057400"/>
-            <a:ext cx="5074920" cy="3840480"/>
+            <a:off x="6391656" y="2011680"/>
+            <a:ext cx="5221224" cy="3931920"/>
           </a:xfrm>
           <a:prstGeom prst="rect">
             <a:avLst/>
@@ -7833,7 +8021,7 @@
           <a:p>
             <a:pPr>
               <a:spcAft>
-                <a:spcPts val="600"/>
+                <a:spcPts val="500"/>
               </a:spcAft>
               <a:defRPr sz="1200">
                 <a:solidFill>
@@ -7849,7 +8037,7 @@
           <a:p>
             <a:pPr>
               <a:spcAft>
-                <a:spcPts val="600"/>
+                <a:spcPts val="500"/>
               </a:spcAft>
               <a:defRPr sz="1200">
                 <a:solidFill>
@@ -7865,7 +8053,7 @@
           <a:p>
             <a:pPr>
               <a:spcAft>
-                <a:spcPts val="600"/>
+                <a:spcPts val="500"/>
               </a:spcAft>
               <a:defRPr sz="1200">
                 <a:solidFill>
@@ -7878,7 +8066,7 @@
           <a:p>
             <a:pPr>
               <a:spcAft>
-                <a:spcPts val="600"/>
+                <a:spcPts val="500"/>
               </a:spcAft>
               <a:defRPr sz="1200">
                 <a:solidFill>
@@ -7894,7 +8082,7 @@
           <a:p>
             <a:pPr>
               <a:spcAft>
-                <a:spcPts val="600"/>
+                <a:spcPts val="500"/>
               </a:spcAft>
               <a:defRPr sz="1200">
                 <a:solidFill>
@@ -7910,7 +8098,7 @@
           <a:p>
             <a:pPr>
               <a:spcAft>
-                <a:spcPts val="600"/>
+                <a:spcPts val="500"/>
               </a:spcAft>
               <a:defRPr sz="1200">
                 <a:solidFill>
@@ -7923,7 +8111,7 @@
           <a:p>
             <a:pPr>
               <a:spcAft>
-                <a:spcPts val="600"/>
+                <a:spcPts val="500"/>
               </a:spcAft>
               <a:defRPr sz="1200">
                 <a:solidFill>
@@ -7939,7 +8127,7 @@
           <a:p>
             <a:pPr>
               <a:spcAft>
-                <a:spcPts val="600"/>
+                <a:spcPts val="500"/>
               </a:spcAft>
               <a:defRPr sz="1200">
                 <a:solidFill>
@@ -7955,7 +8143,7 @@
           <a:p>
             <a:pPr>
               <a:spcAft>
-                <a:spcPts val="600"/>
+                <a:spcPts val="500"/>
               </a:spcAft>
               <a:defRPr sz="1200">
                 <a:solidFill>
@@ -7968,7 +8156,7 @@
           <a:p>
             <a:pPr>
               <a:spcAft>
-                <a:spcPts val="600"/>
+                <a:spcPts val="500"/>
               </a:spcAft>
               <a:defRPr sz="1200">
                 <a:solidFill>
@@ -8151,7 +8339,7 @@
               </a:defRPr>
             </a:pPr>
             <a:r>
-              <a:t>Ready to role-play the Uber EBR live, walk through the Automations demo,</a:t>
+              <a:t>Ready to role-play the Databricks EBR live, walk through the Automations demo,</a:t>
             </a:r>
           </a:p>
           <a:p>
@@ -8401,7 +8589,7 @@
               </a:defRPr>
             </a:pPr>
             <a:r>
-              <a:t>EBR role-play — Business review with Uber Engineering</a:t>
+              <a:t>EBR role-play — Business review with Databricks leadership</a:t>
             </a:r>
           </a:p>
           <a:p>
@@ -10661,8 +10849,8 @@
         </p:nvSpPr>
         <p:spPr>
           <a:xfrm>
-            <a:off x="548640" y="1554480"/>
-            <a:ext cx="5440680" cy="4572000"/>
+            <a:off x="502920" y="1554480"/>
+            <a:ext cx="5495544" cy="4572000"/>
           </a:xfrm>
           <a:prstGeom prst="rect">
             <a:avLst/>
@@ -10706,8 +10894,8 @@
         </p:nvSpPr>
         <p:spPr>
           <a:xfrm>
-            <a:off x="731520" y="1691640"/>
-            <a:ext cx="5074920" cy="457200"/>
+            <a:off x="640080" y="1664208"/>
+            <a:ext cx="5221224" cy="411480"/>
           </a:xfrm>
           <a:prstGeom prst="rect">
             <a:avLst/>
@@ -10742,8 +10930,8 @@
         </p:nvSpPr>
         <p:spPr>
           <a:xfrm>
-            <a:off x="731520" y="2057400"/>
-            <a:ext cx="5074920" cy="3840480"/>
+            <a:off x="640080" y="2011680"/>
+            <a:ext cx="5221224" cy="3931920"/>
           </a:xfrm>
           <a:prstGeom prst="rect">
             <a:avLst/>
@@ -10758,7 +10946,7 @@
           <a:p>
             <a:pPr>
               <a:spcAft>
-                <a:spcPts val="600"/>
+                <a:spcPts val="500"/>
               </a:spcAft>
               <a:defRPr sz="1200">
                 <a:solidFill>
@@ -10774,7 +10962,7 @@
           <a:p>
             <a:pPr>
               <a:spcAft>
-                <a:spcPts val="600"/>
+                <a:spcPts val="500"/>
               </a:spcAft>
               <a:defRPr sz="1200">
                 <a:solidFill>
@@ -10790,7 +10978,7 @@
           <a:p>
             <a:pPr>
               <a:spcAft>
-                <a:spcPts val="600"/>
+                <a:spcPts val="500"/>
               </a:spcAft>
               <a:defRPr sz="1200">
                 <a:solidFill>
@@ -10806,7 +10994,7 @@
           <a:p>
             <a:pPr>
               <a:spcAft>
-                <a:spcPts val="600"/>
+                <a:spcPts val="500"/>
               </a:spcAft>
               <a:defRPr sz="1200">
                 <a:solidFill>
@@ -10829,8 +11017,8 @@
         </p:nvSpPr>
         <p:spPr>
           <a:xfrm>
-            <a:off x="6355080" y="1554480"/>
-            <a:ext cx="5440680" cy="4572000"/>
+            <a:off x="6254496" y="1554480"/>
+            <a:ext cx="5495544" cy="4572000"/>
           </a:xfrm>
           <a:prstGeom prst="rect">
             <a:avLst/>
@@ -10874,8 +11062,8 @@
         </p:nvSpPr>
         <p:spPr>
           <a:xfrm>
-            <a:off x="6537960" y="1691640"/>
-            <a:ext cx="5074920" cy="457200"/>
+            <a:off x="6391656" y="1664208"/>
+            <a:ext cx="5221224" cy="411480"/>
           </a:xfrm>
           <a:prstGeom prst="rect">
             <a:avLst/>
@@ -10910,8 +11098,8 @@
         </p:nvSpPr>
         <p:spPr>
           <a:xfrm>
-            <a:off x="6537960" y="2057400"/>
-            <a:ext cx="5074920" cy="3840480"/>
+            <a:off x="6391656" y="2011680"/>
+            <a:ext cx="5221224" cy="3931920"/>
           </a:xfrm>
           <a:prstGeom prst="rect">
             <a:avLst/>
@@ -10926,7 +11114,7 @@
           <a:p>
             <a:pPr>
               <a:spcAft>
-                <a:spcPts val="600"/>
+                <a:spcPts val="500"/>
               </a:spcAft>
               <a:defRPr sz="1200">
                 <a:solidFill>
@@ -10942,7 +11130,7 @@
           <a:p>
             <a:pPr>
               <a:spcAft>
-                <a:spcPts val="600"/>
+                <a:spcPts val="500"/>
               </a:spcAft>
               <a:defRPr sz="1200">
                 <a:solidFill>
@@ -10958,7 +11146,7 @@
           <a:p>
             <a:pPr>
               <a:spcAft>
-                <a:spcPts val="600"/>
+                <a:spcPts val="500"/>
               </a:spcAft>
               <a:defRPr sz="1200">
                 <a:solidFill>
@@ -10974,7 +11162,7 @@
           <a:p>
             <a:pPr>
               <a:spcAft>
-                <a:spcPts val="600"/>
+                <a:spcPts val="500"/>
               </a:spcAft>
               <a:defRPr sz="1200">
                 <a:solidFill>
@@ -11209,8 +11397,8 @@
         </p:nvSpPr>
         <p:spPr>
           <a:xfrm>
-            <a:off x="548640" y="2011680"/>
-            <a:ext cx="5440680" cy="4572000"/>
+            <a:off x="502920" y="2011680"/>
+            <a:ext cx="5495544" cy="4572000"/>
           </a:xfrm>
           <a:prstGeom prst="rect">
             <a:avLst/>
@@ -11254,8 +11442,8 @@
         </p:nvSpPr>
         <p:spPr>
           <a:xfrm>
-            <a:off x="731520" y="2148840"/>
-            <a:ext cx="5074920" cy="457200"/>
+            <a:off x="640080" y="2121408"/>
+            <a:ext cx="5221224" cy="411480"/>
           </a:xfrm>
           <a:prstGeom prst="rect">
             <a:avLst/>
@@ -11290,8 +11478,8 @@
         </p:nvSpPr>
         <p:spPr>
           <a:xfrm>
-            <a:off x="731520" y="2514600"/>
-            <a:ext cx="5074920" cy="3840480"/>
+            <a:off x="640080" y="2468880"/>
+            <a:ext cx="5221224" cy="3931920"/>
           </a:xfrm>
           <a:prstGeom prst="rect">
             <a:avLst/>
@@ -11306,7 +11494,7 @@
           <a:p>
             <a:pPr>
               <a:spcAft>
-                <a:spcPts val="600"/>
+                <a:spcPts val="500"/>
               </a:spcAft>
               <a:defRPr sz="1200">
                 <a:solidFill>
@@ -11322,7 +11510,7 @@
           <a:p>
             <a:pPr>
               <a:spcAft>
-                <a:spcPts val="600"/>
+                <a:spcPts val="500"/>
               </a:spcAft>
               <a:defRPr sz="1200">
                 <a:solidFill>
@@ -11345,8 +11533,8 @@
         </p:nvSpPr>
         <p:spPr>
           <a:xfrm>
-            <a:off x="6355080" y="2011680"/>
-            <a:ext cx="5440680" cy="4572000"/>
+            <a:off x="6254496" y="2011680"/>
+            <a:ext cx="5495544" cy="4572000"/>
           </a:xfrm>
           <a:prstGeom prst="rect">
             <a:avLst/>
@@ -11390,8 +11578,8 @@
         </p:nvSpPr>
         <p:spPr>
           <a:xfrm>
-            <a:off x="6537960" y="2148840"/>
-            <a:ext cx="5074920" cy="457200"/>
+            <a:off x="6391656" y="2121408"/>
+            <a:ext cx="5221224" cy="411480"/>
           </a:xfrm>
           <a:prstGeom prst="rect">
             <a:avLst/>
@@ -11426,8 +11614,8 @@
         </p:nvSpPr>
         <p:spPr>
           <a:xfrm>
-            <a:off x="6537960" y="2514600"/>
-            <a:ext cx="5074920" cy="3840480"/>
+            <a:off x="6391656" y="2468880"/>
+            <a:ext cx="5221224" cy="3931920"/>
           </a:xfrm>
           <a:prstGeom prst="rect">
             <a:avLst/>
@@ -11442,7 +11630,7 @@
           <a:p>
             <a:pPr>
               <a:spcAft>
-                <a:spcPts val="600"/>
+                <a:spcPts val="500"/>
               </a:spcAft>
               <a:defRPr sz="1200">
                 <a:solidFill>
@@ -11458,7 +11646,7 @@
           <a:p>
             <a:pPr>
               <a:spcAft>
-                <a:spcPts val="600"/>
+                <a:spcPts val="500"/>
               </a:spcAft>
               <a:defRPr sz="1200">
                 <a:solidFill>
@@ -11481,8 +11669,8 @@
         </p:nvSpPr>
         <p:spPr>
           <a:xfrm>
-            <a:off x="12161520" y="2011680"/>
-            <a:ext cx="5440680" cy="4572000"/>
+            <a:off x="12006072" y="2011680"/>
+            <a:ext cx="5495544" cy="4572000"/>
           </a:xfrm>
           <a:prstGeom prst="rect">
             <a:avLst/>
@@ -11526,8 +11714,8 @@
         </p:nvSpPr>
         <p:spPr>
           <a:xfrm>
-            <a:off x="12344400" y="2148840"/>
-            <a:ext cx="5074920" cy="457200"/>
+            <a:off x="12143232" y="2121408"/>
+            <a:ext cx="5221224" cy="411480"/>
           </a:xfrm>
           <a:prstGeom prst="rect">
             <a:avLst/>
@@ -11562,8 +11750,8 @@
         </p:nvSpPr>
         <p:spPr>
           <a:xfrm>
-            <a:off x="12344400" y="2514600"/>
-            <a:ext cx="5074920" cy="3840480"/>
+            <a:off x="12143232" y="2468880"/>
+            <a:ext cx="5221224" cy="3931920"/>
           </a:xfrm>
           <a:prstGeom prst="rect">
             <a:avLst/>
@@ -11578,7 +11766,7 @@
           <a:p>
             <a:pPr>
               <a:spcAft>
-                <a:spcPts val="600"/>
+                <a:spcPts val="500"/>
               </a:spcAft>
               <a:defRPr sz="1200">
                 <a:solidFill>
@@ -11594,7 +11782,7 @@
           <a:p>
             <a:pPr>
               <a:spcAft>
-                <a:spcPts val="600"/>
+                <a:spcPts val="500"/>
               </a:spcAft>
               <a:defRPr sz="1200">
                 <a:solidFill>
@@ -12748,7 +12936,7 @@
               </a:defRPr>
             </a:pPr>
             <a:r>
-              <a:t>Executive Business Review — Uber</a:t>
+              <a:t>Executive Business Review — Databricks</a:t>
             </a:r>
           </a:p>
         </p:txBody>
@@ -12761,8 +12949,8 @@
         </p:nvSpPr>
         <p:spPr>
           <a:xfrm>
-            <a:off x="548640" y="1417320"/>
-            <a:ext cx="11064240" cy="1042416"/>
+            <a:off x="548640" y="1371600"/>
+            <a:ext cx="11064240" cy="749808"/>
           </a:xfrm>
           <a:prstGeom prst="rect">
             <a:avLst/>
@@ -12779,7 +12967,7 @@
               <a:spcAft>
                 <a:spcPts val="600"/>
               </a:spcAft>
-              <a:defRPr sz="1700">
+              <a:defRPr sz="1600">
                 <a:solidFill>
                   <a:srgbClr val="E8EDF5"/>
                 </a:solidFill>
@@ -12787,23 +12975,7 @@
               </a:defRPr>
             </a:pPr>
             <a:r>
-              <a:t>Simulated QBR with James Okonkwo (VP Eng, Marketplace) + Priya Sharma (Dir, Developer Platform)</a:t>
-            </a:r>
-          </a:p>
-          <a:p>
-            <a:pPr>
-              <a:spcAft>
-                <a:spcPts val="600"/>
-              </a:spcAft>
-              <a:defRPr sz="1700">
-                <a:solidFill>
-                  <a:srgbClr val="E8EDF5"/>
-                </a:solidFill>
-                <a:latin typeface="Segoe UI"/>
-              </a:defRPr>
-            </a:pPr>
-            <a:r>
-              <a:t>Account: $980K ARR · 15,423 SWEs · Green health · 7 mo to renewal</a:t>
+              <a:t>Strategic ecosystem partnership · $420K ARR · 5,480 SWEs · 80% active · 4 mo to renewal</a:t>
             </a:r>
           </a:p>
         </p:txBody>
@@ -12816,8 +12988,8 @@
         </p:nvSpPr>
         <p:spPr>
           <a:xfrm>
-            <a:off x="548640" y="2286000"/>
-            <a:ext cx="5440680" cy="4572000"/>
+            <a:off x="502920" y="1965960"/>
+            <a:ext cx="5495544" cy="4572000"/>
           </a:xfrm>
           <a:prstGeom prst="rect">
             <a:avLst/>
@@ -12861,8 +13033,8 @@
         </p:nvSpPr>
         <p:spPr>
           <a:xfrm>
-            <a:off x="731520" y="2423160"/>
-            <a:ext cx="5074920" cy="457200"/>
+            <a:off x="640080" y="2075688"/>
+            <a:ext cx="5221224" cy="411480"/>
           </a:xfrm>
           <a:prstGeom prst="rect">
             <a:avLst/>
@@ -12897,8 +13069,8 @@
         </p:nvSpPr>
         <p:spPr>
           <a:xfrm>
-            <a:off x="731520" y="2788920"/>
-            <a:ext cx="5074920" cy="3840480"/>
+            <a:off x="640080" y="2423160"/>
+            <a:ext cx="5221224" cy="3931920"/>
           </a:xfrm>
           <a:prstGeom prst="rect">
             <a:avLst/>
@@ -12913,7 +13085,7 @@
           <a:p>
             <a:pPr>
               <a:spcAft>
-                <a:spcPts val="600"/>
+                <a:spcPts val="500"/>
               </a:spcAft>
               <a:defRPr sz="1200">
                 <a:solidFill>
@@ -12929,7 +13101,7 @@
           <a:p>
             <a:pPr>
               <a:spcAft>
-                <a:spcPts val="600"/>
+                <a:spcPts val="500"/>
               </a:spcAft>
               <a:defRPr sz="1200">
                 <a:solidFill>
@@ -12945,7 +13117,7 @@
           <a:p>
             <a:pPr>
               <a:spcAft>
-                <a:spcPts val="600"/>
+                <a:spcPts val="500"/>
               </a:spcAft>
               <a:defRPr sz="1200">
                 <a:solidFill>
@@ -12968,8 +13140,8 @@
         </p:nvSpPr>
         <p:spPr>
           <a:xfrm>
-            <a:off x="6355080" y="2286000"/>
-            <a:ext cx="5440680" cy="4572000"/>
+            <a:off x="6254496" y="1965960"/>
+            <a:ext cx="5495544" cy="4572000"/>
           </a:xfrm>
           <a:prstGeom prst="rect">
             <a:avLst/>
@@ -13013,8 +13185,8 @@
         </p:nvSpPr>
         <p:spPr>
           <a:xfrm>
-            <a:off x="6537960" y="2423160"/>
-            <a:ext cx="5074920" cy="457200"/>
+            <a:off x="6391656" y="2075688"/>
+            <a:ext cx="5221224" cy="411480"/>
           </a:xfrm>
           <a:prstGeom prst="rect">
             <a:avLst/>
@@ -13036,7 +13208,7 @@
               </a:defRPr>
             </a:pPr>
             <a:r>
-              <a:t>Attendees — Uber</a:t>
+              <a:t>Attendees — Databricks</a:t>
             </a:r>
           </a:p>
         </p:txBody>
@@ -13049,8 +13221,8 @@
         </p:nvSpPr>
         <p:spPr>
           <a:xfrm>
-            <a:off x="6537960" y="2788920"/>
-            <a:ext cx="5074920" cy="3840480"/>
+            <a:off x="6391656" y="2423160"/>
+            <a:ext cx="5221224" cy="3931920"/>
           </a:xfrm>
           <a:prstGeom prst="rect">
             <a:avLst/>
@@ -13065,7 +13237,7 @@
           <a:p>
             <a:pPr>
               <a:spcAft>
-                <a:spcPts val="600"/>
+                <a:spcPts val="500"/>
               </a:spcAft>
               <a:defRPr sz="1200">
                 <a:solidFill>
@@ -13075,13 +13247,13 @@
               </a:defRPr>
             </a:pPr>
             <a:r>
-              <a:t>James Okonkwo — VP Eng, Marketplace</a:t>
+              <a:t>Naveen Zutshi — Chief Information Officer</a:t>
             </a:r>
           </a:p>
           <a:p>
             <a:pPr>
               <a:spcAft>
-                <a:spcPts val="600"/>
+                <a:spcPts val="500"/>
               </a:spcAft>
               <a:defRPr sz="1200">
                 <a:solidFill>
@@ -13091,13 +13263,13 @@
               </a:defRPr>
             </a:pPr>
             <a:r>
-              <a:t>Priya Sharma — Dir, Developer Platform</a:t>
+              <a:t>Bruce Wong — Head of Data Platform</a:t>
             </a:r>
           </a:p>
           <a:p>
             <a:pPr>
               <a:spcAft>
-                <a:spcPts val="600"/>
+                <a:spcPts val="500"/>
               </a:spcAft>
               <a:defRPr sz="1200">
                 <a:solidFill>
@@ -13107,7 +13279,7 @@
               </a:defRPr>
             </a:pPr>
             <a:r>
-              <a:t>Elena Vasquez — Staff Eng, AI DevEx (optional)</a:t>
+              <a:t>Sam Shah — VP of Engineering</a:t>
             </a:r>
           </a:p>
         </p:txBody>

</xml_diff>